<commit_message>
Product- Creating necessary files and DB columns
</commit_message>
<xml_diff>
--- a/.lessons/58 Backend Product And Related Features/8 Product- Creating necessary files and DB columns/1.pptx
+++ b/.lessons/58 Backend Product And Related Features/8 Product- Creating necessary files and DB columns/1.pptx
@@ -7,7 +7,13 @@
   <p:sldIdLst>
     <p:sldId id="413" r:id="rId2"/>
     <p:sldId id="414" r:id="rId3"/>
-    <p:sldId id="400" r:id="rId4"/>
+    <p:sldId id="415" r:id="rId4"/>
+    <p:sldId id="416" r:id="rId5"/>
+    <p:sldId id="417" r:id="rId6"/>
+    <p:sldId id="418" r:id="rId7"/>
+    <p:sldId id="419" r:id="rId8"/>
+    <p:sldId id="420" r:id="rId9"/>
+    <p:sldId id="400" r:id="rId10"/>
   </p:sldIdLst>
   <p:sldSz cx="12192000" cy="6858000"/>
   <p:notesSz cx="6858000" cy="9144000"/>
@@ -261,7 +267,7 @@
           <a:p>
             <a:fld id="{3E102D2E-813C-461C-9963-687A650C48C0}" type="datetimeFigureOut">
               <a:rPr lang="en-US" smtClean="0"/>
-              <a:t>6/26/2025</a:t>
+              <a:t>9/9/2025</a:t>
             </a:fld>
             <a:endParaRPr lang="en-US"/>
           </a:p>
@@ -459,7 +465,7 @@
           <a:p>
             <a:fld id="{3E102D2E-813C-461C-9963-687A650C48C0}" type="datetimeFigureOut">
               <a:rPr lang="en-US" smtClean="0"/>
-              <a:t>6/26/2025</a:t>
+              <a:t>9/9/2025</a:t>
             </a:fld>
             <a:endParaRPr lang="en-US"/>
           </a:p>
@@ -667,7 +673,7 @@
           <a:p>
             <a:fld id="{3E102D2E-813C-461C-9963-687A650C48C0}" type="datetimeFigureOut">
               <a:rPr lang="en-US" smtClean="0"/>
-              <a:t>6/26/2025</a:t>
+              <a:t>9/9/2025</a:t>
             </a:fld>
             <a:endParaRPr lang="en-US"/>
           </a:p>
@@ -865,7 +871,7 @@
           <a:p>
             <a:fld id="{3E102D2E-813C-461C-9963-687A650C48C0}" type="datetimeFigureOut">
               <a:rPr lang="en-US" smtClean="0"/>
-              <a:t>6/26/2025</a:t>
+              <a:t>9/9/2025</a:t>
             </a:fld>
             <a:endParaRPr lang="en-US"/>
           </a:p>
@@ -1140,7 +1146,7 @@
           <a:p>
             <a:fld id="{3E102D2E-813C-461C-9963-687A650C48C0}" type="datetimeFigureOut">
               <a:rPr lang="en-US" smtClean="0"/>
-              <a:t>6/26/2025</a:t>
+              <a:t>9/9/2025</a:t>
             </a:fld>
             <a:endParaRPr lang="en-US"/>
           </a:p>
@@ -1405,7 +1411,7 @@
           <a:p>
             <a:fld id="{3E102D2E-813C-461C-9963-687A650C48C0}" type="datetimeFigureOut">
               <a:rPr lang="en-US" smtClean="0"/>
-              <a:t>6/26/2025</a:t>
+              <a:t>9/9/2025</a:t>
             </a:fld>
             <a:endParaRPr lang="en-US"/>
           </a:p>
@@ -1817,7 +1823,7 @@
           <a:p>
             <a:fld id="{3E102D2E-813C-461C-9963-687A650C48C0}" type="datetimeFigureOut">
               <a:rPr lang="en-US" smtClean="0"/>
-              <a:t>6/26/2025</a:t>
+              <a:t>9/9/2025</a:t>
             </a:fld>
             <a:endParaRPr lang="en-US"/>
           </a:p>
@@ -1958,7 +1964,7 @@
           <a:p>
             <a:fld id="{3E102D2E-813C-461C-9963-687A650C48C0}" type="datetimeFigureOut">
               <a:rPr lang="en-US" smtClean="0"/>
-              <a:t>6/26/2025</a:t>
+              <a:t>9/9/2025</a:t>
             </a:fld>
             <a:endParaRPr lang="en-US"/>
           </a:p>
@@ -2071,7 +2077,7 @@
           <a:p>
             <a:fld id="{3E102D2E-813C-461C-9963-687A650C48C0}" type="datetimeFigureOut">
               <a:rPr lang="en-US" smtClean="0"/>
-              <a:t>6/26/2025</a:t>
+              <a:t>9/9/2025</a:t>
             </a:fld>
             <a:endParaRPr lang="en-US"/>
           </a:p>
@@ -2382,7 +2388,7 @@
           <a:p>
             <a:fld id="{3E102D2E-813C-461C-9963-687A650C48C0}" type="datetimeFigureOut">
               <a:rPr lang="en-US" smtClean="0"/>
-              <a:t>6/26/2025</a:t>
+              <a:t>9/9/2025</a:t>
             </a:fld>
             <a:endParaRPr lang="en-US"/>
           </a:p>
@@ -2670,7 +2676,7 @@
           <a:p>
             <a:fld id="{3E102D2E-813C-461C-9963-687A650C48C0}" type="datetimeFigureOut">
               <a:rPr lang="en-US" smtClean="0"/>
-              <a:t>6/26/2025</a:t>
+              <a:t>9/9/2025</a:t>
             </a:fld>
             <a:endParaRPr lang="en-US"/>
           </a:p>
@@ -2911,7 +2917,7 @@
           <a:p>
             <a:fld id="{3E102D2E-813C-461C-9963-687A650C48C0}" type="datetimeFigureOut">
               <a:rPr lang="en-US" smtClean="0"/>
-              <a:t>6/26/2025</a:t>
+              <a:t>9/9/2025</a:t>
             </a:fld>
             <a:endParaRPr lang="en-US"/>
           </a:p>
@@ -3348,7 +3354,7 @@
         </p:nvSpPr>
         <p:spPr>
           <a:xfrm>
-            <a:off x="217714" y="255046"/>
+            <a:off x="217714" y="181155"/>
             <a:ext cx="11756571" cy="355354"/>
           </a:xfrm>
           <a:prstGeom prst="rect">
@@ -3369,21 +3375,90 @@
               <a:buNone/>
             </a:pPr>
             <a:r>
-              <a:rPr kumimoji="0" lang="en-US" altLang="en-US" sz="1300" b="0" i="0" u="none" strike="noStrike" cap="none" normalizeH="0" baseline="0">
-                <a:ln>
-                  <a:noFill/>
-                </a:ln>
-                <a:solidFill>
-                  <a:schemeClr val="tx1"/>
-                </a:solidFill>
-                <a:effectLst/>
-                <a:latin typeface="Arial" panose="020B0604020202020204" pitchFamily="34" charset="0"/>
-              </a:rPr>
-              <a:t>.</a:t>
-            </a:r>
-          </a:p>
-        </p:txBody>
-      </p:sp>
+              <a:rPr lang="en-US" altLang="en-US" sz="1300" b="1">
+                <a:latin typeface="Arial" panose="020B0604020202020204" pitchFamily="34" charset="0"/>
+              </a:rPr>
+              <a:t>Product</a:t>
+            </a:r>
+            <a:r>
+              <a:rPr lang="en-US" altLang="en-US" sz="1300">
+                <a:latin typeface="Arial" panose="020B0604020202020204" pitchFamily="34" charset="0"/>
+              </a:rPr>
+              <a:t> </a:t>
+            </a:r>
+            <a:r>
+              <a:rPr lang="az-Latn-AZ" altLang="en-US" sz="1300">
+                <a:latin typeface="Arial" panose="020B0604020202020204" pitchFamily="34" charset="0"/>
+              </a:rPr>
+              <a:t>əlavə etmək üçün istifadə edəcəyimiz </a:t>
+            </a:r>
+            <a:r>
+              <a:rPr lang="az-Latn-AZ" altLang="en-US" sz="1300" b="1">
+                <a:latin typeface="Arial" panose="020B0604020202020204" pitchFamily="34" charset="0"/>
+              </a:rPr>
+              <a:t>controller</a:t>
+            </a:r>
+            <a:r>
+              <a:rPr lang="az-Latn-AZ" altLang="en-US" sz="1300">
+                <a:latin typeface="Arial" panose="020B0604020202020204" pitchFamily="34" charset="0"/>
+              </a:rPr>
+              <a:t> və </a:t>
+            </a:r>
+            <a:r>
+              <a:rPr lang="az-Latn-AZ" altLang="en-US" sz="1300" b="1">
+                <a:latin typeface="Arial" panose="020B0604020202020204" pitchFamily="34" charset="0"/>
+              </a:rPr>
+              <a:t>model</a:t>
+            </a:r>
+            <a:r>
+              <a:rPr lang="az-Latn-AZ" altLang="en-US" sz="1300">
+                <a:latin typeface="Arial" panose="020B0604020202020204" pitchFamily="34" charset="0"/>
+              </a:rPr>
+              <a:t> -i yaradırıq.</a:t>
+            </a:r>
+            <a:endParaRPr kumimoji="0" lang="en-US" altLang="en-US" sz="1300" b="0" i="0" u="none" strike="noStrike" cap="none" normalizeH="0" baseline="0">
+              <a:ln>
+                <a:noFill/>
+              </a:ln>
+              <a:solidFill>
+                <a:schemeClr val="tx1"/>
+              </a:solidFill>
+              <a:effectLst/>
+              <a:latin typeface="Arial" panose="020B0604020202020204" pitchFamily="34" charset="0"/>
+            </a:endParaRPr>
+          </a:p>
+        </p:txBody>
+      </p:sp>
+      <p:pic>
+        <p:nvPicPr>
+          <p:cNvPr id="4" name="Picture 3">
+            <a:extLst>
+              <a:ext uri="{FF2B5EF4-FFF2-40B4-BE49-F238E27FC236}">
+                <a16:creationId xmlns:a16="http://schemas.microsoft.com/office/drawing/2014/main" id="{D39EC8BF-3DF0-AFC9-4B69-06552590D77B}"/>
+              </a:ext>
+            </a:extLst>
+          </p:cNvPr>
+          <p:cNvPicPr>
+            <a:picLocks noChangeAspect="1"/>
+          </p:cNvPicPr>
+          <p:nvPr/>
+        </p:nvPicPr>
+        <p:blipFill>
+          <a:blip r:embed="rId2"/>
+          <a:stretch>
+            <a:fillRect/>
+          </a:stretch>
+        </p:blipFill>
+        <p:spPr>
+          <a:xfrm>
+            <a:off x="2456091" y="4314470"/>
+            <a:ext cx="9735909" cy="2543530"/>
+          </a:xfrm>
+          <a:prstGeom prst="rect">
+            <a:avLst/>
+          </a:prstGeom>
+        </p:spPr>
+      </p:pic>
     </p:spTree>
     <p:extLst>
       <p:ext uri="{BB962C8B-B14F-4D97-AF65-F5344CB8AC3E}">
@@ -3435,7 +3510,7 @@
         <p:spPr>
           <a:xfrm>
             <a:off x="217714" y="255046"/>
-            <a:ext cx="11756571" cy="355354"/>
+            <a:ext cx="7734795" cy="6152133"/>
           </a:xfrm>
           <a:prstGeom prst="rect">
             <a:avLst/>
@@ -3455,21 +3530,480 @@
               <a:buNone/>
             </a:pPr>
             <a:r>
-              <a:rPr kumimoji="0" lang="en-US" altLang="en-US" sz="1300" b="0" i="0" u="none" strike="noStrike" cap="none" normalizeH="0" baseline="0">
-                <a:ln>
-                  <a:noFill/>
-                </a:ln>
-                <a:solidFill>
-                  <a:schemeClr val="tx1"/>
-                </a:solidFill>
-                <a:effectLst/>
-                <a:latin typeface="Arial" panose="020B0604020202020204" pitchFamily="34" charset="0"/>
-              </a:rPr>
-              <a:t>.</a:t>
-            </a:r>
-          </a:p>
-        </p:txBody>
-      </p:sp>
+              <a:rPr lang="en-US" altLang="en-US" sz="1200">
+                <a:latin typeface="Arial" panose="020B0604020202020204" pitchFamily="34" charset="0"/>
+              </a:rPr>
+              <a:t>database\migrations\2025_09_09_141731_create_products_table.php</a:t>
+            </a:r>
+            <a:endParaRPr lang="az-Latn-AZ" altLang="en-US" sz="1200">
+              <a:latin typeface="Arial" panose="020B0604020202020204" pitchFamily="34" charset="0"/>
+            </a:endParaRPr>
+          </a:p>
+          <a:p>
+            <a:pPr>
+              <a:lnSpc>
+                <a:spcPct val="150000"/>
+              </a:lnSpc>
+              <a:buNone/>
+            </a:pPr>
+            <a:endParaRPr kumimoji="0" lang="az-Latn-AZ" altLang="en-US" sz="1200" b="0" i="0" u="none" strike="noStrike" cap="none" normalizeH="0" baseline="0">
+              <a:ln>
+                <a:noFill/>
+              </a:ln>
+              <a:solidFill>
+                <a:schemeClr val="tx1"/>
+              </a:solidFill>
+              <a:effectLst/>
+              <a:latin typeface="Arial" panose="020B0604020202020204" pitchFamily="34" charset="0"/>
+            </a:endParaRPr>
+          </a:p>
+          <a:p>
+            <a:pPr>
+              <a:lnSpc>
+                <a:spcPct val="150000"/>
+              </a:lnSpc>
+              <a:buNone/>
+            </a:pPr>
+            <a:r>
+              <a:rPr lang="en-US" altLang="en-US" sz="1200">
+                <a:latin typeface="Arial" panose="020B0604020202020204" pitchFamily="34" charset="0"/>
+              </a:rPr>
+              <a:t>Bu sütunların hamısı məhsulun (product) xüsusiyyətlərini və SEO parametrlərini saxlamaq üçün istifadə olunur.</a:t>
+            </a:r>
+            <a:endParaRPr lang="az-Latn-AZ" altLang="en-US" sz="1200">
+              <a:latin typeface="Arial" panose="020B0604020202020204" pitchFamily="34" charset="0"/>
+            </a:endParaRPr>
+          </a:p>
+          <a:p>
+            <a:pPr>
+              <a:lnSpc>
+                <a:spcPct val="150000"/>
+              </a:lnSpc>
+              <a:buNone/>
+            </a:pPr>
+            <a:endParaRPr kumimoji="0" lang="az-Latn-AZ" altLang="en-US" sz="1200" b="0" i="0" u="none" strike="noStrike" cap="none" normalizeH="0" baseline="0">
+              <a:ln>
+                <a:noFill/>
+              </a:ln>
+              <a:solidFill>
+                <a:schemeClr val="tx1"/>
+              </a:solidFill>
+              <a:effectLst/>
+              <a:latin typeface="Arial" panose="020B0604020202020204" pitchFamily="34" charset="0"/>
+            </a:endParaRPr>
+          </a:p>
+          <a:p>
+            <a:pPr>
+              <a:lnSpc>
+                <a:spcPct val="150000"/>
+              </a:lnSpc>
+              <a:buNone/>
+            </a:pPr>
+            <a:endParaRPr lang="az-Latn-AZ" altLang="en-US" sz="1200">
+              <a:latin typeface="Arial" panose="020B0604020202020204" pitchFamily="34" charset="0"/>
+            </a:endParaRPr>
+          </a:p>
+          <a:p>
+            <a:pPr marL="285750" indent="-285750">
+              <a:lnSpc>
+                <a:spcPct val="150000"/>
+              </a:lnSpc>
+              <a:buFont typeface="Arial" panose="020B0604020202020204" pitchFamily="34" charset="0"/>
+              <a:buChar char="•"/>
+            </a:pPr>
+            <a:r>
+              <a:rPr lang="en-US" altLang="en-US" sz="1200" b="1">
+                <a:latin typeface="Arial" panose="020B0604020202020204" pitchFamily="34" charset="0"/>
+              </a:rPr>
+              <a:t>is_top </a:t>
+            </a:r>
+            <a:r>
+              <a:rPr lang="en-US" altLang="en-US" sz="1200">
+                <a:latin typeface="Arial" panose="020B0604020202020204" pitchFamily="34" charset="0"/>
+              </a:rPr>
+              <a:t>→ məhsul “Top Product” kimi işarələnibmi? (məs: saytın “Top Products” bölməsində görünsün).</a:t>
+            </a:r>
+          </a:p>
+          <a:p>
+            <a:pPr marL="285750" indent="-285750">
+              <a:lnSpc>
+                <a:spcPct val="150000"/>
+              </a:lnSpc>
+              <a:buFont typeface="Arial" panose="020B0604020202020204" pitchFamily="34" charset="0"/>
+              <a:buChar char="•"/>
+            </a:pPr>
+            <a:r>
+              <a:rPr lang="en-US" altLang="en-US" sz="1200" b="1">
+                <a:latin typeface="Arial" panose="020B0604020202020204" pitchFamily="34" charset="0"/>
+              </a:rPr>
+              <a:t>is_best </a:t>
+            </a:r>
+            <a:r>
+              <a:rPr lang="en-US" altLang="en-US" sz="1200">
+                <a:latin typeface="Arial" panose="020B0604020202020204" pitchFamily="34" charset="0"/>
+              </a:rPr>
+              <a:t>→ məhsul “Best Seller” və ya “Best Choice” kimi işarələnibmi?</a:t>
+            </a:r>
+          </a:p>
+          <a:p>
+            <a:pPr marL="285750" indent="-285750">
+              <a:lnSpc>
+                <a:spcPct val="150000"/>
+              </a:lnSpc>
+              <a:buFont typeface="Arial" panose="020B0604020202020204" pitchFamily="34" charset="0"/>
+              <a:buChar char="•"/>
+            </a:pPr>
+            <a:r>
+              <a:rPr lang="en-US" altLang="en-US" sz="1200" b="1">
+                <a:latin typeface="Arial" panose="020B0604020202020204" pitchFamily="34" charset="0"/>
+              </a:rPr>
+              <a:t>is_featured </a:t>
+            </a:r>
+            <a:r>
+              <a:rPr lang="en-US" altLang="en-US" sz="1200">
+                <a:latin typeface="Arial" panose="020B0604020202020204" pitchFamily="34" charset="0"/>
+              </a:rPr>
+              <a:t>→ məhsul “Featured” (önə çıxarılmış) məhsul kimi göstərilsinmi?</a:t>
+            </a:r>
+          </a:p>
+          <a:p>
+            <a:pPr marL="285750" indent="-285750">
+              <a:lnSpc>
+                <a:spcPct val="150000"/>
+              </a:lnSpc>
+              <a:buFont typeface="Arial" panose="020B0604020202020204" pitchFamily="34" charset="0"/>
+              <a:buChar char="•"/>
+            </a:pPr>
+            <a:r>
+              <a:rPr lang="en-US" altLang="en-US" sz="1200" b="1">
+                <a:latin typeface="Arial" panose="020B0604020202020204" pitchFamily="34" charset="0"/>
+              </a:rPr>
+              <a:t>is_approved </a:t>
+            </a:r>
+            <a:r>
+              <a:rPr lang="en-US" altLang="en-US" sz="1200">
+                <a:latin typeface="Arial" panose="020B0604020202020204" pitchFamily="34" charset="0"/>
+              </a:rPr>
+              <a:t>→ məhsul admin tərəfindən təsdiqlənibmi?</a:t>
+            </a:r>
+          </a:p>
+          <a:p>
+            <a:pPr lvl="1">
+              <a:lnSpc>
+                <a:spcPct val="150000"/>
+              </a:lnSpc>
+            </a:pPr>
+            <a:r>
+              <a:rPr lang="en-US" altLang="en-US" sz="1200" b="1">
+                <a:latin typeface="Arial" panose="020B0604020202020204" pitchFamily="34" charset="0"/>
+              </a:rPr>
+              <a:t>0</a:t>
+            </a:r>
+            <a:r>
+              <a:rPr lang="en-US" altLang="en-US" sz="1200">
+                <a:latin typeface="Arial" panose="020B0604020202020204" pitchFamily="34" charset="0"/>
+              </a:rPr>
+              <a:t> → təsdiqlənməyib</a:t>
+            </a:r>
+          </a:p>
+          <a:p>
+            <a:pPr lvl="1">
+              <a:lnSpc>
+                <a:spcPct val="150000"/>
+              </a:lnSpc>
+            </a:pPr>
+            <a:r>
+              <a:rPr lang="en-US" altLang="en-US" sz="1200" b="1">
+                <a:latin typeface="Arial" panose="020B0604020202020204" pitchFamily="34" charset="0"/>
+              </a:rPr>
+              <a:t>1</a:t>
+            </a:r>
+            <a:r>
+              <a:rPr lang="en-US" altLang="en-US" sz="1200">
+                <a:latin typeface="Arial" panose="020B0604020202020204" pitchFamily="34" charset="0"/>
+              </a:rPr>
+              <a:t> → təsdiqlənib</a:t>
+            </a:r>
+            <a:endParaRPr lang="az-Latn-AZ" altLang="en-US" sz="1200">
+              <a:latin typeface="Arial" panose="020B0604020202020204" pitchFamily="34" charset="0"/>
+            </a:endParaRPr>
+          </a:p>
+          <a:p>
+            <a:pPr lvl="1">
+              <a:lnSpc>
+                <a:spcPct val="150000"/>
+              </a:lnSpc>
+            </a:pPr>
+            <a:endParaRPr lang="en-US" altLang="en-US" sz="1200">
+              <a:latin typeface="Arial" panose="020B0604020202020204" pitchFamily="34" charset="0"/>
+            </a:endParaRPr>
+          </a:p>
+          <a:p>
+            <a:pPr>
+              <a:lnSpc>
+                <a:spcPct val="150000"/>
+              </a:lnSpc>
+              <a:buNone/>
+            </a:pPr>
+            <a:r>
+              <a:rPr lang="en-US" altLang="en-US" sz="1200">
+                <a:latin typeface="Arial" panose="020B0604020202020204" pitchFamily="34" charset="0"/>
+              </a:rPr>
+              <a:t>(Bu, çox vaxt marketplace-lərdə olur: satıcı əlavə edir, amma </a:t>
+            </a:r>
+            <a:r>
+              <a:rPr lang="en-US" altLang="en-US" sz="1200" b="1">
+                <a:latin typeface="Arial" panose="020B0604020202020204" pitchFamily="34" charset="0"/>
+              </a:rPr>
+              <a:t>admin</a:t>
+            </a:r>
+            <a:r>
+              <a:rPr lang="en-US" altLang="en-US" sz="1200">
+                <a:latin typeface="Arial" panose="020B0604020202020204" pitchFamily="34" charset="0"/>
+              </a:rPr>
+              <a:t> təsdiqləyənə qədər məhsul göstərilmir.)</a:t>
+            </a:r>
+          </a:p>
+          <a:p>
+            <a:pPr>
+              <a:lnSpc>
+                <a:spcPct val="150000"/>
+              </a:lnSpc>
+              <a:buNone/>
+            </a:pPr>
+            <a:endParaRPr lang="en-US" altLang="en-US" sz="1200">
+              <a:latin typeface="Arial" panose="020B0604020202020204" pitchFamily="34" charset="0"/>
+            </a:endParaRPr>
+          </a:p>
+          <a:p>
+            <a:pPr>
+              <a:lnSpc>
+                <a:spcPct val="150000"/>
+              </a:lnSpc>
+              <a:buNone/>
+            </a:pPr>
+            <a:r>
+              <a:rPr lang="en-US" altLang="en-US" sz="1200">
+                <a:latin typeface="Arial" panose="020B0604020202020204" pitchFamily="34" charset="0"/>
+              </a:rPr>
+              <a:t>📌 Qeyd: </a:t>
+            </a:r>
+            <a:r>
+              <a:rPr lang="en-US" altLang="en-US" sz="1200" b="1">
+                <a:latin typeface="Arial" panose="020B0604020202020204" pitchFamily="34" charset="0"/>
+              </a:rPr>
+              <a:t>is_top</a:t>
+            </a:r>
+            <a:r>
+              <a:rPr lang="en-US" altLang="en-US" sz="1200">
+                <a:latin typeface="Arial" panose="020B0604020202020204" pitchFamily="34" charset="0"/>
+              </a:rPr>
+              <a:t>, </a:t>
+            </a:r>
+            <a:r>
+              <a:rPr lang="en-US" altLang="en-US" sz="1200" b="1">
+                <a:latin typeface="Arial" panose="020B0604020202020204" pitchFamily="34" charset="0"/>
+              </a:rPr>
+              <a:t>is_best</a:t>
+            </a:r>
+            <a:r>
+              <a:rPr lang="en-US" altLang="en-US" sz="1200">
+                <a:latin typeface="Arial" panose="020B0604020202020204" pitchFamily="34" charset="0"/>
+              </a:rPr>
+              <a:t>, </a:t>
+            </a:r>
+            <a:r>
+              <a:rPr lang="en-US" altLang="en-US" sz="1200" b="1">
+                <a:latin typeface="Arial" panose="020B0604020202020204" pitchFamily="34" charset="0"/>
+              </a:rPr>
+              <a:t>is_featured </a:t>
+            </a:r>
+            <a:r>
+              <a:rPr lang="en-US" altLang="en-US" sz="1200">
+                <a:latin typeface="Arial" panose="020B0604020202020204" pitchFamily="34" charset="0"/>
+              </a:rPr>
+              <a:t>üçün </a:t>
+            </a:r>
+            <a:r>
+              <a:rPr lang="en-US" altLang="en-US" sz="1200" b="1">
+                <a:latin typeface="Arial" panose="020B0604020202020204" pitchFamily="34" charset="0"/>
+              </a:rPr>
+              <a:t>string</a:t>
+            </a:r>
+            <a:r>
+              <a:rPr lang="en-US" altLang="en-US" sz="1200">
+                <a:latin typeface="Arial" panose="020B0604020202020204" pitchFamily="34" charset="0"/>
+              </a:rPr>
+              <a:t> əvəzinə </a:t>
+            </a:r>
+            <a:r>
+              <a:rPr lang="en-US" altLang="en-US" sz="1200" b="1">
+                <a:latin typeface="Arial" panose="020B0604020202020204" pitchFamily="34" charset="0"/>
+              </a:rPr>
+              <a:t>boolean</a:t>
+            </a:r>
+            <a:r>
+              <a:rPr lang="en-US" altLang="en-US" sz="1200">
+                <a:latin typeface="Arial" panose="020B0604020202020204" pitchFamily="34" charset="0"/>
+              </a:rPr>
+              <a:t> və ya </a:t>
+            </a:r>
+            <a:r>
+              <a:rPr lang="en-US" altLang="en-US" sz="1200" b="1">
+                <a:latin typeface="Arial" panose="020B0604020202020204" pitchFamily="34" charset="0"/>
+              </a:rPr>
+              <a:t>tinyInteger</a:t>
+            </a:r>
+            <a:r>
+              <a:rPr lang="en-US" altLang="en-US" sz="1200">
+                <a:latin typeface="Arial" panose="020B0604020202020204" pitchFamily="34" charset="0"/>
+              </a:rPr>
+              <a:t> istifadə etmək daha düzgündür, çünki bunlar adətən </a:t>
+            </a:r>
+            <a:r>
+              <a:rPr lang="en-US" altLang="en-US" sz="1200" b="1">
+                <a:latin typeface="Arial" panose="020B0604020202020204" pitchFamily="34" charset="0"/>
+              </a:rPr>
+              <a:t>0/1</a:t>
+            </a:r>
+            <a:r>
+              <a:rPr lang="en-US" altLang="en-US" sz="1200">
+                <a:latin typeface="Arial" panose="020B0604020202020204" pitchFamily="34" charset="0"/>
+              </a:rPr>
+              <a:t> tipli dəyərlərdir.</a:t>
+            </a:r>
+            <a:r>
+              <a:rPr lang="az-Latn-AZ" altLang="en-US" sz="1200">
+                <a:latin typeface="Arial" panose="020B0604020202020204" pitchFamily="34" charset="0"/>
+              </a:rPr>
+              <a:t> Biz hələki müvəqqəti olaraq string yazaq çünki sonra ola bilsin həmin bu sütun adlarını `</a:t>
+            </a:r>
+            <a:r>
+              <a:rPr lang="az-Latn-AZ" altLang="en-US" sz="1200" b="1">
+                <a:latin typeface="Arial" panose="020B0604020202020204" pitchFamily="34" charset="0"/>
+              </a:rPr>
+              <a:t>product_type</a:t>
+            </a:r>
+            <a:r>
+              <a:rPr lang="az-Latn-AZ" altLang="en-US" sz="1200">
+                <a:latin typeface="Arial" panose="020B0604020202020204" pitchFamily="34" charset="0"/>
+              </a:rPr>
+              <a:t>` olaraq dəyişdik.</a:t>
+            </a:r>
+          </a:p>
+          <a:p>
+            <a:pPr>
+              <a:lnSpc>
+                <a:spcPct val="150000"/>
+              </a:lnSpc>
+              <a:buNone/>
+            </a:pPr>
+            <a:endParaRPr kumimoji="0" lang="az-Latn-AZ" altLang="en-US" sz="1200" b="0" i="0" u="none" strike="noStrike" cap="none" normalizeH="0" baseline="0">
+              <a:ln>
+                <a:noFill/>
+              </a:ln>
+              <a:solidFill>
+                <a:schemeClr val="tx1"/>
+              </a:solidFill>
+              <a:effectLst/>
+              <a:latin typeface="Arial" panose="020B0604020202020204" pitchFamily="34" charset="0"/>
+            </a:endParaRPr>
+          </a:p>
+          <a:p>
+            <a:pPr>
+              <a:lnSpc>
+                <a:spcPct val="150000"/>
+              </a:lnSpc>
+              <a:buNone/>
+            </a:pPr>
+            <a:endParaRPr lang="az-Latn-AZ" altLang="en-US" sz="1200">
+              <a:latin typeface="Arial" panose="020B0604020202020204" pitchFamily="34" charset="0"/>
+            </a:endParaRPr>
+          </a:p>
+          <a:p>
+            <a:pPr marL="171450" indent="-171450">
+              <a:lnSpc>
+                <a:spcPct val="150000"/>
+              </a:lnSpc>
+              <a:buFont typeface="Arial" panose="020B0604020202020204" pitchFamily="34" charset="0"/>
+              <a:buChar char="•"/>
+            </a:pPr>
+            <a:r>
+              <a:rPr lang="en-US" altLang="en-US" sz="1200" b="1">
+                <a:latin typeface="Arial" panose="020B0604020202020204" pitchFamily="34" charset="0"/>
+              </a:rPr>
+              <a:t>seo_title </a:t>
+            </a:r>
+            <a:r>
+              <a:rPr lang="en-US" altLang="en-US" sz="1200">
+                <a:latin typeface="Arial" panose="020B0604020202020204" pitchFamily="34" charset="0"/>
+              </a:rPr>
+              <a:t>→ məhsul səhifəsinin title etiketi üçün xüsusi başlıq (Google, Bing axtarış nəticələrində görsənir).</a:t>
+            </a:r>
+          </a:p>
+          <a:p>
+            <a:pPr marL="171450" indent="-171450">
+              <a:lnSpc>
+                <a:spcPct val="150000"/>
+              </a:lnSpc>
+              <a:buFont typeface="Arial" panose="020B0604020202020204" pitchFamily="34" charset="0"/>
+              <a:buChar char="•"/>
+            </a:pPr>
+            <a:r>
+              <a:rPr lang="en-US" altLang="en-US" sz="1200" b="1">
+                <a:latin typeface="Arial" panose="020B0604020202020204" pitchFamily="34" charset="0"/>
+              </a:rPr>
+              <a:t>seo_description </a:t>
+            </a:r>
+            <a:r>
+              <a:rPr lang="en-US" altLang="en-US" sz="1200">
+                <a:latin typeface="Arial" panose="020B0604020202020204" pitchFamily="34" charset="0"/>
+              </a:rPr>
+              <a:t>→ məhsul səhifəsinin meta description etiketi (axtarış nəticələrində məhsul haqqında qısa mətn).</a:t>
+            </a:r>
+            <a:endParaRPr kumimoji="0" lang="en-US" altLang="en-US" sz="1200" b="0" i="0" u="none" strike="noStrike" cap="none" normalizeH="0" baseline="0">
+              <a:ln>
+                <a:noFill/>
+              </a:ln>
+              <a:solidFill>
+                <a:schemeClr val="tx1"/>
+              </a:solidFill>
+              <a:effectLst/>
+              <a:latin typeface="Arial" panose="020B0604020202020204" pitchFamily="34" charset="0"/>
+            </a:endParaRPr>
+          </a:p>
+        </p:txBody>
+      </p:sp>
+      <p:pic>
+        <p:nvPicPr>
+          <p:cNvPr id="4" name="Picture 3">
+            <a:extLst>
+              <a:ext uri="{FF2B5EF4-FFF2-40B4-BE49-F238E27FC236}">
+                <a16:creationId xmlns:a16="http://schemas.microsoft.com/office/drawing/2014/main" id="{F24B478D-729B-1A0B-AB56-BAAC50293514}"/>
+              </a:ext>
+            </a:extLst>
+          </p:cNvPr>
+          <p:cNvPicPr>
+            <a:picLocks noChangeAspect="1"/>
+          </p:cNvPicPr>
+          <p:nvPr/>
+        </p:nvPicPr>
+        <p:blipFill>
+          <a:blip r:embed="rId2"/>
+          <a:stretch>
+            <a:fillRect/>
+          </a:stretch>
+        </p:blipFill>
+        <p:spPr>
+          <a:xfrm>
+            <a:off x="8130878" y="0"/>
+            <a:ext cx="4061122" cy="6858000"/>
+          </a:xfrm>
+          <a:prstGeom prst="rect">
+            <a:avLst/>
+          </a:prstGeom>
+        </p:spPr>
+      </p:pic>
     </p:spTree>
     <p:extLst>
       <p:ext uri="{BB962C8B-B14F-4D97-AF65-F5344CB8AC3E}">
@@ -3484,6 +4018,596 @@
 </file>
 
 <file path=ppt/slides/slide3.xml><?xml version="1.0" encoding="utf-8"?>
+<p:sld xmlns:a="http://schemas.openxmlformats.org/drawingml/2006/main" xmlns:r="http://schemas.openxmlformats.org/officeDocument/2006/relationships" xmlns:p="http://schemas.openxmlformats.org/presentationml/2006/main">
+  <p:cSld>
+    <p:spTree>
+      <p:nvGrpSpPr>
+        <p:cNvPr id="1" name="">
+          <a:extLst>
+            <a:ext uri="{FF2B5EF4-FFF2-40B4-BE49-F238E27FC236}">
+              <a16:creationId xmlns:a16="http://schemas.microsoft.com/office/drawing/2014/main" id="{EB413AFD-78AA-50C6-C381-7E8B7C843826}"/>
+            </a:ext>
+          </a:extLst>
+        </p:cNvPr>
+        <p:cNvGrpSpPr/>
+        <p:nvPr/>
+      </p:nvGrpSpPr>
+      <p:grpSpPr>
+        <a:xfrm>
+          <a:off x="0" y="0"/>
+          <a:ext cx="0" cy="0"/>
+          <a:chOff x="0" y="0"/>
+          <a:chExt cx="0" cy="0"/>
+        </a:xfrm>
+      </p:grpSpPr>
+      <p:sp>
+        <p:nvSpPr>
+          <p:cNvPr id="3" name="TextBox 2">
+            <a:extLst>
+              <a:ext uri="{FF2B5EF4-FFF2-40B4-BE49-F238E27FC236}">
+                <a16:creationId xmlns:a16="http://schemas.microsoft.com/office/drawing/2014/main" id="{C26F4C34-B17E-620C-E4BD-B31EE2E22F13}"/>
+              </a:ext>
+            </a:extLst>
+          </p:cNvPr>
+          <p:cNvSpPr txBox="1"/>
+          <p:nvPr/>
+        </p:nvSpPr>
+        <p:spPr>
+          <a:xfrm>
+            <a:off x="217714" y="255046"/>
+            <a:ext cx="11756571" cy="355354"/>
+          </a:xfrm>
+          <a:prstGeom prst="rect">
+            <a:avLst/>
+          </a:prstGeom>
+          <a:noFill/>
+        </p:spPr>
+        <p:txBody>
+          <a:bodyPr wrap="square">
+            <a:spAutoFit/>
+          </a:bodyPr>
+          <a:lstStyle/>
+          <a:p>
+            <a:pPr>
+              <a:lnSpc>
+                <a:spcPct val="150000"/>
+              </a:lnSpc>
+              <a:buNone/>
+            </a:pPr>
+            <a:r>
+              <a:rPr kumimoji="0" lang="en-US" altLang="en-US" sz="1300" b="0" i="0" u="none" strike="noStrike" cap="none" normalizeH="0" baseline="0">
+                <a:ln>
+                  <a:noFill/>
+                </a:ln>
+                <a:solidFill>
+                  <a:schemeClr val="tx1"/>
+                </a:solidFill>
+                <a:effectLst/>
+                <a:latin typeface="Arial" panose="020B0604020202020204" pitchFamily="34" charset="0"/>
+              </a:rPr>
+              <a:t>.</a:t>
+            </a:r>
+          </a:p>
+        </p:txBody>
+      </p:sp>
+      <p:pic>
+        <p:nvPicPr>
+          <p:cNvPr id="4" name="Picture 3">
+            <a:extLst>
+              <a:ext uri="{FF2B5EF4-FFF2-40B4-BE49-F238E27FC236}">
+                <a16:creationId xmlns:a16="http://schemas.microsoft.com/office/drawing/2014/main" id="{8F94DBAD-8C48-19D4-EAFD-4203481F4F01}"/>
+              </a:ext>
+            </a:extLst>
+          </p:cNvPr>
+          <p:cNvPicPr>
+            <a:picLocks noChangeAspect="1"/>
+          </p:cNvPicPr>
+          <p:nvPr/>
+        </p:nvPicPr>
+        <p:blipFill>
+          <a:blip r:embed="rId2"/>
+          <a:stretch>
+            <a:fillRect/>
+          </a:stretch>
+        </p:blipFill>
+        <p:spPr>
+          <a:xfrm>
+            <a:off x="1827354" y="4733629"/>
+            <a:ext cx="10364646" cy="2124371"/>
+          </a:xfrm>
+          <a:prstGeom prst="rect">
+            <a:avLst/>
+          </a:prstGeom>
+        </p:spPr>
+      </p:pic>
+    </p:spTree>
+    <p:extLst>
+      <p:ext uri="{BB962C8B-B14F-4D97-AF65-F5344CB8AC3E}">
+        <p14:creationId xmlns:p14="http://schemas.microsoft.com/office/powerpoint/2010/main" val="3711212622"/>
+      </p:ext>
+    </p:extLst>
+  </p:cSld>
+  <p:clrMapOvr>
+    <a:masterClrMapping/>
+  </p:clrMapOvr>
+</p:sld>
+</file>
+
+<file path=ppt/slides/slide4.xml><?xml version="1.0" encoding="utf-8"?>
+<p:sld xmlns:a="http://schemas.openxmlformats.org/drawingml/2006/main" xmlns:r="http://schemas.openxmlformats.org/officeDocument/2006/relationships" xmlns:p="http://schemas.openxmlformats.org/presentationml/2006/main">
+  <p:cSld>
+    <p:spTree>
+      <p:nvGrpSpPr>
+        <p:cNvPr id="1" name="">
+          <a:extLst>
+            <a:ext uri="{FF2B5EF4-FFF2-40B4-BE49-F238E27FC236}">
+              <a16:creationId xmlns:a16="http://schemas.microsoft.com/office/drawing/2014/main" id="{8EBE4E0F-1A2C-DE7A-6520-55AE39F559B8}"/>
+            </a:ext>
+          </a:extLst>
+        </p:cNvPr>
+        <p:cNvGrpSpPr/>
+        <p:nvPr/>
+      </p:nvGrpSpPr>
+      <p:grpSpPr>
+        <a:xfrm>
+          <a:off x="0" y="0"/>
+          <a:ext cx="0" cy="0"/>
+          <a:chOff x="0" y="0"/>
+          <a:chExt cx="0" cy="0"/>
+        </a:xfrm>
+      </p:grpSpPr>
+      <p:sp>
+        <p:nvSpPr>
+          <p:cNvPr id="3" name="TextBox 2">
+            <a:extLst>
+              <a:ext uri="{FF2B5EF4-FFF2-40B4-BE49-F238E27FC236}">
+                <a16:creationId xmlns:a16="http://schemas.microsoft.com/office/drawing/2014/main" id="{4E4E6343-65A1-8489-BCEE-F5278429227C}"/>
+              </a:ext>
+            </a:extLst>
+          </p:cNvPr>
+          <p:cNvSpPr txBox="1"/>
+          <p:nvPr/>
+        </p:nvSpPr>
+        <p:spPr>
+          <a:xfrm>
+            <a:off x="217714" y="255046"/>
+            <a:ext cx="11756571" cy="355354"/>
+          </a:xfrm>
+          <a:prstGeom prst="rect">
+            <a:avLst/>
+          </a:prstGeom>
+          <a:noFill/>
+        </p:spPr>
+        <p:txBody>
+          <a:bodyPr wrap="square">
+            <a:spAutoFit/>
+          </a:bodyPr>
+          <a:lstStyle/>
+          <a:p>
+            <a:pPr>
+              <a:lnSpc>
+                <a:spcPct val="150000"/>
+              </a:lnSpc>
+              <a:buNone/>
+            </a:pPr>
+            <a:r>
+              <a:rPr kumimoji="0" lang="en-US" altLang="en-US" sz="1300" b="0" i="0" u="none" strike="noStrike" cap="none" normalizeH="0" baseline="0">
+                <a:ln>
+                  <a:noFill/>
+                </a:ln>
+                <a:solidFill>
+                  <a:schemeClr val="tx1"/>
+                </a:solidFill>
+                <a:effectLst/>
+                <a:latin typeface="Arial" panose="020B0604020202020204" pitchFamily="34" charset="0"/>
+              </a:rPr>
+              <a:t>.</a:t>
+            </a:r>
+          </a:p>
+        </p:txBody>
+      </p:sp>
+      <p:pic>
+        <p:nvPicPr>
+          <p:cNvPr id="4" name="Picture 3">
+            <a:extLst>
+              <a:ext uri="{FF2B5EF4-FFF2-40B4-BE49-F238E27FC236}">
+                <a16:creationId xmlns:a16="http://schemas.microsoft.com/office/drawing/2014/main" id="{E388D288-360B-4DBA-16CF-7A0C0601BBB0}"/>
+              </a:ext>
+            </a:extLst>
+          </p:cNvPr>
+          <p:cNvPicPr>
+            <a:picLocks noChangeAspect="1"/>
+          </p:cNvPicPr>
+          <p:nvPr/>
+        </p:nvPicPr>
+        <p:blipFill>
+          <a:blip r:embed="rId2"/>
+          <a:stretch>
+            <a:fillRect/>
+          </a:stretch>
+        </p:blipFill>
+        <p:spPr>
+          <a:xfrm>
+            <a:off x="0" y="3134961"/>
+            <a:ext cx="12192000" cy="3723039"/>
+          </a:xfrm>
+          <a:prstGeom prst="rect">
+            <a:avLst/>
+          </a:prstGeom>
+          <a:ln w="38100" cap="sq">
+            <a:solidFill>
+              <a:srgbClr val="000000"/>
+            </a:solidFill>
+            <a:prstDash val="solid"/>
+            <a:miter lim="800000"/>
+          </a:ln>
+          <a:effectLst>
+            <a:outerShdw blurRad="50800" dist="38100" dir="2700000" algn="tl" rotWithShape="0">
+              <a:srgbClr val="000000">
+                <a:alpha val="43000"/>
+              </a:srgbClr>
+            </a:outerShdw>
+          </a:effectLst>
+        </p:spPr>
+      </p:pic>
+    </p:spTree>
+    <p:extLst>
+      <p:ext uri="{BB962C8B-B14F-4D97-AF65-F5344CB8AC3E}">
+        <p14:creationId xmlns:p14="http://schemas.microsoft.com/office/powerpoint/2010/main" val="3251998284"/>
+      </p:ext>
+    </p:extLst>
+  </p:cSld>
+  <p:clrMapOvr>
+    <a:masterClrMapping/>
+  </p:clrMapOvr>
+</p:sld>
+</file>
+
+<file path=ppt/slides/slide5.xml><?xml version="1.0" encoding="utf-8"?>
+<p:sld xmlns:a="http://schemas.openxmlformats.org/drawingml/2006/main" xmlns:r="http://schemas.openxmlformats.org/officeDocument/2006/relationships" xmlns:p="http://schemas.openxmlformats.org/presentationml/2006/main">
+  <p:cSld>
+    <p:spTree>
+      <p:nvGrpSpPr>
+        <p:cNvPr id="1" name="">
+          <a:extLst>
+            <a:ext uri="{FF2B5EF4-FFF2-40B4-BE49-F238E27FC236}">
+              <a16:creationId xmlns:a16="http://schemas.microsoft.com/office/drawing/2014/main" id="{A4EDCA4B-AD0F-7B55-4864-FBBCEF9E5A1E}"/>
+            </a:ext>
+          </a:extLst>
+        </p:cNvPr>
+        <p:cNvGrpSpPr/>
+        <p:nvPr/>
+      </p:nvGrpSpPr>
+      <p:grpSpPr>
+        <a:xfrm>
+          <a:off x="0" y="0"/>
+          <a:ext cx="0" cy="0"/>
+          <a:chOff x="0" y="0"/>
+          <a:chExt cx="0" cy="0"/>
+        </a:xfrm>
+      </p:grpSpPr>
+      <p:sp>
+        <p:nvSpPr>
+          <p:cNvPr id="3" name="TextBox 2">
+            <a:extLst>
+              <a:ext uri="{FF2B5EF4-FFF2-40B4-BE49-F238E27FC236}">
+                <a16:creationId xmlns:a16="http://schemas.microsoft.com/office/drawing/2014/main" id="{C02E948E-6E20-CA3E-16B2-01F5D9713696}"/>
+              </a:ext>
+            </a:extLst>
+          </p:cNvPr>
+          <p:cNvSpPr txBox="1"/>
+          <p:nvPr/>
+        </p:nvSpPr>
+        <p:spPr>
+          <a:xfrm>
+            <a:off x="217714" y="255046"/>
+            <a:ext cx="11756571" cy="355354"/>
+          </a:xfrm>
+          <a:prstGeom prst="rect">
+            <a:avLst/>
+          </a:prstGeom>
+          <a:noFill/>
+        </p:spPr>
+        <p:txBody>
+          <a:bodyPr wrap="square">
+            <a:spAutoFit/>
+          </a:bodyPr>
+          <a:lstStyle/>
+          <a:p>
+            <a:pPr>
+              <a:lnSpc>
+                <a:spcPct val="150000"/>
+              </a:lnSpc>
+              <a:buNone/>
+            </a:pPr>
+            <a:r>
+              <a:rPr kumimoji="0" lang="en-US" altLang="en-US" sz="1300" b="0" i="0" u="none" strike="noStrike" cap="none" normalizeH="0" baseline="0">
+                <a:ln>
+                  <a:noFill/>
+                </a:ln>
+                <a:solidFill>
+                  <a:schemeClr val="tx1"/>
+                </a:solidFill>
+                <a:effectLst/>
+                <a:latin typeface="Arial" panose="020B0604020202020204" pitchFamily="34" charset="0"/>
+              </a:rPr>
+              <a:t>.</a:t>
+            </a:r>
+          </a:p>
+        </p:txBody>
+      </p:sp>
+    </p:spTree>
+    <p:extLst>
+      <p:ext uri="{BB962C8B-B14F-4D97-AF65-F5344CB8AC3E}">
+        <p14:creationId xmlns:p14="http://schemas.microsoft.com/office/powerpoint/2010/main" val="1508612854"/>
+      </p:ext>
+    </p:extLst>
+  </p:cSld>
+  <p:clrMapOvr>
+    <a:masterClrMapping/>
+  </p:clrMapOvr>
+</p:sld>
+</file>
+
+<file path=ppt/slides/slide6.xml><?xml version="1.0" encoding="utf-8"?>
+<p:sld xmlns:a="http://schemas.openxmlformats.org/drawingml/2006/main" xmlns:r="http://schemas.openxmlformats.org/officeDocument/2006/relationships" xmlns:p="http://schemas.openxmlformats.org/presentationml/2006/main">
+  <p:cSld>
+    <p:spTree>
+      <p:nvGrpSpPr>
+        <p:cNvPr id="1" name="">
+          <a:extLst>
+            <a:ext uri="{FF2B5EF4-FFF2-40B4-BE49-F238E27FC236}">
+              <a16:creationId xmlns:a16="http://schemas.microsoft.com/office/drawing/2014/main" id="{0793EE3D-86FA-9CA3-FFFF-F1914F84EC93}"/>
+            </a:ext>
+          </a:extLst>
+        </p:cNvPr>
+        <p:cNvGrpSpPr/>
+        <p:nvPr/>
+      </p:nvGrpSpPr>
+      <p:grpSpPr>
+        <a:xfrm>
+          <a:off x="0" y="0"/>
+          <a:ext cx="0" cy="0"/>
+          <a:chOff x="0" y="0"/>
+          <a:chExt cx="0" cy="0"/>
+        </a:xfrm>
+      </p:grpSpPr>
+      <p:sp>
+        <p:nvSpPr>
+          <p:cNvPr id="3" name="TextBox 2">
+            <a:extLst>
+              <a:ext uri="{FF2B5EF4-FFF2-40B4-BE49-F238E27FC236}">
+                <a16:creationId xmlns:a16="http://schemas.microsoft.com/office/drawing/2014/main" id="{64BD4F70-B0AC-2066-2717-3FEF0CEF2AFF}"/>
+              </a:ext>
+            </a:extLst>
+          </p:cNvPr>
+          <p:cNvSpPr txBox="1"/>
+          <p:nvPr/>
+        </p:nvSpPr>
+        <p:spPr>
+          <a:xfrm>
+            <a:off x="217714" y="255046"/>
+            <a:ext cx="11756571" cy="355354"/>
+          </a:xfrm>
+          <a:prstGeom prst="rect">
+            <a:avLst/>
+          </a:prstGeom>
+          <a:noFill/>
+        </p:spPr>
+        <p:txBody>
+          <a:bodyPr wrap="square">
+            <a:spAutoFit/>
+          </a:bodyPr>
+          <a:lstStyle/>
+          <a:p>
+            <a:pPr>
+              <a:lnSpc>
+                <a:spcPct val="150000"/>
+              </a:lnSpc>
+              <a:buNone/>
+            </a:pPr>
+            <a:r>
+              <a:rPr kumimoji="0" lang="en-US" altLang="en-US" sz="1300" b="0" i="0" u="none" strike="noStrike" cap="none" normalizeH="0" baseline="0">
+                <a:ln>
+                  <a:noFill/>
+                </a:ln>
+                <a:solidFill>
+                  <a:schemeClr val="tx1"/>
+                </a:solidFill>
+                <a:effectLst/>
+                <a:latin typeface="Arial" panose="020B0604020202020204" pitchFamily="34" charset="0"/>
+              </a:rPr>
+              <a:t>.</a:t>
+            </a:r>
+          </a:p>
+        </p:txBody>
+      </p:sp>
+    </p:spTree>
+    <p:extLst>
+      <p:ext uri="{BB962C8B-B14F-4D97-AF65-F5344CB8AC3E}">
+        <p14:creationId xmlns:p14="http://schemas.microsoft.com/office/powerpoint/2010/main" val="3703899580"/>
+      </p:ext>
+    </p:extLst>
+  </p:cSld>
+  <p:clrMapOvr>
+    <a:masterClrMapping/>
+  </p:clrMapOvr>
+</p:sld>
+</file>
+
+<file path=ppt/slides/slide7.xml><?xml version="1.0" encoding="utf-8"?>
+<p:sld xmlns:a="http://schemas.openxmlformats.org/drawingml/2006/main" xmlns:r="http://schemas.openxmlformats.org/officeDocument/2006/relationships" xmlns:p="http://schemas.openxmlformats.org/presentationml/2006/main">
+  <p:cSld>
+    <p:spTree>
+      <p:nvGrpSpPr>
+        <p:cNvPr id="1" name="">
+          <a:extLst>
+            <a:ext uri="{FF2B5EF4-FFF2-40B4-BE49-F238E27FC236}">
+              <a16:creationId xmlns:a16="http://schemas.microsoft.com/office/drawing/2014/main" id="{38105BE4-4084-C6E1-C863-AF00433C2BA8}"/>
+            </a:ext>
+          </a:extLst>
+        </p:cNvPr>
+        <p:cNvGrpSpPr/>
+        <p:nvPr/>
+      </p:nvGrpSpPr>
+      <p:grpSpPr>
+        <a:xfrm>
+          <a:off x="0" y="0"/>
+          <a:ext cx="0" cy="0"/>
+          <a:chOff x="0" y="0"/>
+          <a:chExt cx="0" cy="0"/>
+        </a:xfrm>
+      </p:grpSpPr>
+      <p:sp>
+        <p:nvSpPr>
+          <p:cNvPr id="3" name="TextBox 2">
+            <a:extLst>
+              <a:ext uri="{FF2B5EF4-FFF2-40B4-BE49-F238E27FC236}">
+                <a16:creationId xmlns:a16="http://schemas.microsoft.com/office/drawing/2014/main" id="{1F1792B0-98FD-9FB4-F86F-032C0A0F04BE}"/>
+              </a:ext>
+            </a:extLst>
+          </p:cNvPr>
+          <p:cNvSpPr txBox="1"/>
+          <p:nvPr/>
+        </p:nvSpPr>
+        <p:spPr>
+          <a:xfrm>
+            <a:off x="217714" y="255046"/>
+            <a:ext cx="11756571" cy="355354"/>
+          </a:xfrm>
+          <a:prstGeom prst="rect">
+            <a:avLst/>
+          </a:prstGeom>
+          <a:noFill/>
+        </p:spPr>
+        <p:txBody>
+          <a:bodyPr wrap="square">
+            <a:spAutoFit/>
+          </a:bodyPr>
+          <a:lstStyle/>
+          <a:p>
+            <a:pPr>
+              <a:lnSpc>
+                <a:spcPct val="150000"/>
+              </a:lnSpc>
+              <a:buNone/>
+            </a:pPr>
+            <a:r>
+              <a:rPr kumimoji="0" lang="en-US" altLang="en-US" sz="1300" b="0" i="0" u="none" strike="noStrike" cap="none" normalizeH="0" baseline="0">
+                <a:ln>
+                  <a:noFill/>
+                </a:ln>
+                <a:solidFill>
+                  <a:schemeClr val="tx1"/>
+                </a:solidFill>
+                <a:effectLst/>
+                <a:latin typeface="Arial" panose="020B0604020202020204" pitchFamily="34" charset="0"/>
+              </a:rPr>
+              <a:t>.</a:t>
+            </a:r>
+          </a:p>
+        </p:txBody>
+      </p:sp>
+    </p:spTree>
+    <p:extLst>
+      <p:ext uri="{BB962C8B-B14F-4D97-AF65-F5344CB8AC3E}">
+        <p14:creationId xmlns:p14="http://schemas.microsoft.com/office/powerpoint/2010/main" val="2191217816"/>
+      </p:ext>
+    </p:extLst>
+  </p:cSld>
+  <p:clrMapOvr>
+    <a:masterClrMapping/>
+  </p:clrMapOvr>
+</p:sld>
+</file>
+
+<file path=ppt/slides/slide8.xml><?xml version="1.0" encoding="utf-8"?>
+<p:sld xmlns:a="http://schemas.openxmlformats.org/drawingml/2006/main" xmlns:r="http://schemas.openxmlformats.org/officeDocument/2006/relationships" xmlns:p="http://schemas.openxmlformats.org/presentationml/2006/main">
+  <p:cSld>
+    <p:spTree>
+      <p:nvGrpSpPr>
+        <p:cNvPr id="1" name="">
+          <a:extLst>
+            <a:ext uri="{FF2B5EF4-FFF2-40B4-BE49-F238E27FC236}">
+              <a16:creationId xmlns:a16="http://schemas.microsoft.com/office/drawing/2014/main" id="{6DB09B89-F404-A9A6-FE00-79B7D611368A}"/>
+            </a:ext>
+          </a:extLst>
+        </p:cNvPr>
+        <p:cNvGrpSpPr/>
+        <p:nvPr/>
+      </p:nvGrpSpPr>
+      <p:grpSpPr>
+        <a:xfrm>
+          <a:off x="0" y="0"/>
+          <a:ext cx="0" cy="0"/>
+          <a:chOff x="0" y="0"/>
+          <a:chExt cx="0" cy="0"/>
+        </a:xfrm>
+      </p:grpSpPr>
+      <p:sp>
+        <p:nvSpPr>
+          <p:cNvPr id="3" name="TextBox 2">
+            <a:extLst>
+              <a:ext uri="{FF2B5EF4-FFF2-40B4-BE49-F238E27FC236}">
+                <a16:creationId xmlns:a16="http://schemas.microsoft.com/office/drawing/2014/main" id="{83E71345-0EF3-9D35-C1AA-EBF01068EBAD}"/>
+              </a:ext>
+            </a:extLst>
+          </p:cNvPr>
+          <p:cNvSpPr txBox="1"/>
+          <p:nvPr/>
+        </p:nvSpPr>
+        <p:spPr>
+          <a:xfrm>
+            <a:off x="217714" y="255046"/>
+            <a:ext cx="11756571" cy="355354"/>
+          </a:xfrm>
+          <a:prstGeom prst="rect">
+            <a:avLst/>
+          </a:prstGeom>
+          <a:noFill/>
+        </p:spPr>
+        <p:txBody>
+          <a:bodyPr wrap="square">
+            <a:spAutoFit/>
+          </a:bodyPr>
+          <a:lstStyle/>
+          <a:p>
+            <a:pPr>
+              <a:lnSpc>
+                <a:spcPct val="150000"/>
+              </a:lnSpc>
+              <a:buNone/>
+            </a:pPr>
+            <a:r>
+              <a:rPr kumimoji="0" lang="en-US" altLang="en-US" sz="1300" b="0" i="0" u="none" strike="noStrike" cap="none" normalizeH="0" baseline="0">
+                <a:ln>
+                  <a:noFill/>
+                </a:ln>
+                <a:solidFill>
+                  <a:schemeClr val="tx1"/>
+                </a:solidFill>
+                <a:effectLst/>
+                <a:latin typeface="Arial" panose="020B0604020202020204" pitchFamily="34" charset="0"/>
+              </a:rPr>
+              <a:t>.</a:t>
+            </a:r>
+          </a:p>
+        </p:txBody>
+      </p:sp>
+    </p:spTree>
+    <p:extLst>
+      <p:ext uri="{BB962C8B-B14F-4D97-AF65-F5344CB8AC3E}">
+        <p14:creationId xmlns:p14="http://schemas.microsoft.com/office/powerpoint/2010/main" val="4243017066"/>
+      </p:ext>
+    </p:extLst>
+  </p:cSld>
+  <p:clrMapOvr>
+    <a:masterClrMapping/>
+  </p:clrMapOvr>
+</p:sld>
+</file>
+
+<file path=ppt/slides/slide9.xml><?xml version="1.0" encoding="utf-8"?>
 <p:sld xmlns:a="http://schemas.openxmlformats.org/drawingml/2006/main" xmlns:r="http://schemas.openxmlformats.org/officeDocument/2006/relationships" xmlns:p="http://schemas.openxmlformats.org/presentationml/2006/main">
   <p:cSld>
     <p:spTree>

</xml_diff>